<commit_message>
docs (#175): Correct slides 3, 9, 11 and 16 of the Sprint A decks
- Slide 3: n = 30 for 80 % and 2.97, n = 31 for 87 % (report, User Research)
- Slide 9 notes: eleven ADRs accepted, ADR-007 Proposed, ADR-011 authorised
- Slide 11: 377 € is infrastructure (358 € cloud); six databases from Sprint B;
  local extra cost is zero (operating-cost-estimation.md §3, §4.4)
- Slide 16: only the approval is required by ruleset 26232165; CI green and
  resolved conversations are Definition of Done items

Applied to the original, T/TP and PL decks; every other zip entry is unchanged.

Co-Authored-By: Claude Opus 5.5 <noreply@anthropic.com>
</commit_message>
<xml_diff>
--- a/Docs/Presentation/Farol_Sprint_A_PL_Presentation.pptx
+++ b/Docs/Presentation/Farol_Sprint_A_PL_Presentation.pptx
@@ -722,7 +722,7 @@
           <a:p>
             <a:r>
               <a:rPr lang="en-US" dirty="0"/>
-              <a:t>(~50 s) Os custos, com salários e infraestrutura, como o professor pediu. O desenvolvimento do projeto inteiro, com seis papéis a tempo inteiro durante 3,35 meses, custa cerca de 58 500 euros, quase tudo salários. A manutenção, com uma pessoa e produção na cloud, custa cerca de 3 400 euros por mês. Desenvolvimento mais o primeiro ano dá perto de 100 mil euros, a ordem de grandeza para uma organização. A entrega é local por causa do custo: localmente só pagamos o Copilot, enquanto a demo na cloud custaria cerca de 300 euros e a operação contínua 358 euros por mês, contra um crédito único de estudante de 89 euros. O professor autorizou a entrega local.</a:t>
+              <a:t>(~50 s) Os custos, com salários e infraestrutura, como o professor pediu. O desenvolvimento do projeto inteiro, com seis papéis a tempo inteiro durante 3,35 meses, custa cerca de 58 500 euros, quase tudo salários. A manutenção, com uma pessoa e produção na cloud, custa cerca de 3 400 euros por mês. Desenvolvimento mais o primeiro ano dá perto de 100 mil euros, a ordem de grandeza para uma organização. A entrega é local por causa do custo: localmente o custo extra é zero, porque o Copilot é igual nos dois cenários e a equipa usa-o grátis pelo GitHub Education, enquanto a demo na cloud custaria cerca de 300 euros e a operação contínua 358 euros por mês, contra um crédito único de estudante de 89 euros. O professor autorizou a entrega local.</a:t>
             </a:r>
             <a:endParaRPr lang="en-US" dirty="0"/>
           </a:p>
@@ -986,7 +986,7 @@
           <a:p>
             <a:r>
               <a:rPr lang="en-US" dirty="0"/>
-              <a:t>(~45 s) Trabalhamos com GitHub Flow. Todo o trabalho começa numa issue; a regra é uma user story, uma issue, um pull request. O branch é curto, o PR passa pela verificação automática das convenções, pelo pipeline de CI e pela aprovação de outro membro, e entra com squash merge. A revisão do Copilot é pedida em todos os PRs, mas até agora falhou sempre por falta de quota. O main está sempre pronto a entregar. Temos duas reuniões por semana: o planeamento na aula e o stand-up ao fim de semana, mais a review com os investidores no fim de cada sprint. O board do GitHub Projects segue o estado de cada item, de Backlog a Done.</a:t>
+              <a:t>(~45 s) Trabalhamos com GitHub Flow. Todo o trabalho começa numa issue; a regra é uma user story, uma issue, um pull request. O branch é curto, o PR passa pela verificação automática das convenções, pelo pipeline de CI e pela aprovação de outro membro, e entra com squash merge. O GitHub só obriga à aprovação; o CI verde e as conversas resolvidas fazem parte da Definition of Done e são verificados na revisão. A revisão do Copilot está ligada no ruleset, mas até agora falhou sempre por falta de quota. O main está sempre pronto a entregar. Temos duas reuniões por semana: o planeamento na aula e o stand-up ao fim de semana, mais a review com os investidores no fim de cada sprint. O board do GitHub Projects segue o estado de cada item, de Backlog a Done.</a:t>
             </a:r>
             <a:endParaRPr lang="en-US" dirty="0"/>
           </a:p>
@@ -1338,7 +1338,7 @@
           <a:p>
             <a:r>
               <a:rPr lang="en-US" dirty="0"/>
-              <a:t>(~45 s) A stack: Java 21 com Spring Boot 4 no backend, uma aplicação React no frontend, PostgreSQL com Flyway, RabbitMQ para mensagens, Keycloak para identidade e Spring Cloud Gateway à entrada. A entrega usa GitHub Actions, com análise de qualidade no SonarQube Cloud, e Docker Compose, e os testes de carga usam k6. Todas as decisões estão em 13 ADRs, cada um com a escolha, as alternativas e o porquê. Estão todos aceites; nos da IA e da observabilidade falta ainda a evidência a correr, que chega com o Sprint B.</a:t>
+              <a:t>(~45 s) A stack: Java 21 com Spring Boot 4 no backend, uma aplicação React no frontend, PostgreSQL com Flyway, RabbitMQ para mensagens, Keycloak para identidade e Spring Cloud Gateway à entrada. A entrega usa GitHub Actions, com análise de qualidade no SonarQube Cloud, e Docker Compose, e os testes de carga usam k6. Todas as decisões estão em 13 ADRs, cada um com a escolha, as alternativas e o porquê. Onze estão aceites; o do mapa, o ADR-007, ainda está proposto, e o ADR-011 regista a entrega local autorizada pelo professor. Nos da IA e da observabilidade falta ainda a evidência a correr, que chega com o Sprint B.</a:t>
             </a:r>
             <a:endParaRPr lang="en-US" dirty="0"/>
           </a:p>
@@ -3773,7 +3773,7 @@
                   <a:schemeClr val="accent3"/>
                 </a:solidFill>
               </a:rPr>
-              <a:t>1 FTE + 377 € a month of cloud</a:t>
+              <a:t>1 FTE + 377 € a month of infrastructure (358 € cloud)</a:t>
             </a:r>
             <a:endParaRPr lang="en-US" sz="1200" dirty="0"/>
           </a:p>
@@ -4001,7 +4001,7 @@
                   <a:schemeClr val="bg1"/>
                 </a:solidFill>
               </a:rPr>
-              <a:t>Local: 0 € beyond Copilot (notional 102 €/month), same five services and databases on a laptop</a:t>
+              <a:t>Local: 0 € beyond Copilot (notional 102 €/month), from Sprint B the five services and six databases on a laptop</a:t>
             </a:r>
             <a:endParaRPr lang="en-US" sz="1300" dirty="0"/>
           </a:p>
@@ -7051,7 +7051,7 @@
                   <a:schemeClr val="tx1"/>
                 </a:solidFill>
               </a:rPr>
-              <a:t>CI green: build, tests, image, smoke test</a:t>
+              <a:t>Required on main: one team approval</a:t>
             </a:r>
             <a:endParaRPr lang="en-US" sz="1300" dirty="0"/>
           </a:p>
@@ -7069,7 +7069,7 @@
                   <a:schemeClr val="tx1"/>
                 </a:solidFill>
               </a:rPr>
-              <a:t>One team approval (Copilot also requested)</a:t>
+              <a:t>DoD: CI green (build, tests, image, smoke test)</a:t>
             </a:r>
             <a:endParaRPr lang="en-US" sz="1300" dirty="0"/>
           </a:p>
@@ -7087,7 +7087,7 @@
                   <a:schemeClr val="tx1"/>
                 </a:solidFill>
               </a:rPr>
-              <a:t>All conversations resolved</a:t>
+              <a:t>DoD: all conversations resolved</a:t>
             </a:r>
             <a:endParaRPr lang="en-US" sz="1300" dirty="0"/>
           </a:p>

</xml_diff>